<commit_message>
Add Keynote-style blue template with starry background
- Add mvccc_master_keynote_blue.pptx based on Keynote worship slides design
- Deep blue/purple starry background with white text
- Remove hardcoded verse footnote color from slides.py (now template-driven)
- Keep mvccc_keynote_bg.jpeg as the background image source
</commit_message>
<xml_diff>
--- a/mvccc_master_modern_dark.pptx
+++ b/mvccc_master_modern_dark.pptx
@@ -4258,7 +4258,7 @@
         <a:srgbClr val="0B0F14"/>
       </a:lt1>
       <a:dk2>
-        <a:srgbClr val="A7A7A7"/>
+        <a:srgbClr val="F6C453"/>
       </a:dk2>
       <a:lt2>
         <a:srgbClr val="535353"/>
@@ -5312,7 +5312,7 @@
         <a:srgbClr val="FFFFFF"/>
       </a:lt1>
       <a:dk2>
-        <a:srgbClr val="A7A7A7"/>
+        <a:srgbClr val="F6C453"/>
       </a:dk2>
       <a:lt2>
         <a:srgbClr val="535353"/>

</xml_diff>